<commit_message>
Limpia notas y aclaraciones, formatea números en español y amplía la guía
- Elimina notas del orador de la presentación y aclaraciones en REFLEXION.md,
  mercado.md, README.md, GUIA.md y la web de resultados
- Diapositiva 7: resultados del agente en lugar de pasos de demostración
- GUIA.md: cómo abrir la terminal de VS Code y qué es localhost:8501
- Frontend y skill: números con punto de miles y coma decimal

Co-Authored-By: Claude Opus 5.5 <noreply@anthropic.com>
</commit_message>
<xml_diff>
--- a/presentacion/CreditGuard_AI.pptx
+++ b/presentacion/CreditGuard_AI.pptx
@@ -116,17 +116,17 @@
   <p:extLst>
     <p:ext uri="{521415D9-36F7-43E2-AB2F-B90AF26B5E84}">
       <p14:sectionLst xmlns:p14="http://schemas.microsoft.com/office/powerpoint/2010/main">
-        <p14:section name="Apertura" id="{d303fc0c-5994-b7c7-3d20-a3228595e0b4}">
+        <p14:section name="Apertura" id="{0dc50e27-08b8-db70-17d3-847b7965cb6c}">
           <p14:sldIdLst>
             <p14:sldId id="256"/>
           </p14:sldIdLst>
         </p14:section>
-        <p14:section name="1. Problema y oportunidad" id="{4291804f-510c-6851-5078-d76518052fb5}">
+        <p14:section name="1. Problema y oportunidad" id="{85131cc5-8d92-ee1d-31d7-b9bd53bbdbed}">
           <p14:sldIdLst>
             <p14:sldId id="257"/>
           </p14:sldIdLst>
         </p14:section>
-        <p14:section name="2. Arquitectura, Skills, MCP y datos" id="{8cc8bb15-a887-59a2-af8a-279bbbdecc6e}">
+        <p14:section name="2. Arquitectura, Skills, MCP y datos" id="{65875220-a790-4979-7b30-5b3852b2a692}">
           <p14:sldIdLst>
             <p14:sldId id="258"/>
             <p14:sldId id="259"/>
@@ -134,18 +134,18 @@
             <p14:sldId id="261"/>
           </p14:sldIdLst>
         </p14:section>
-        <p14:section name="3. Demostración" id="{951ce3e1-d51c-7db3-631b-2793394125b6}">
+        <p14:section name="3. Resultados" id="{2994514a-5631-4617-b27a-ca1020d36de1}">
           <p14:sldIdLst>
             <p14:sldId id="262"/>
           </p14:sldIdLst>
         </p14:section>
-        <p14:section name="4. Pruebas y errores" id="{b3d88893-363a-7b26-cca1-86a6361ed53f}">
+        <p14:section name="4. Pruebas y errores" id="{dc65a56a-4129-a4f6-3850-40f86c24b725}">
           <p14:sldIdLst>
             <p14:sldId id="263"/>
             <p14:sldId id="264"/>
           </p14:sldIdLst>
         </p14:section>
-        <p14:section name="5. Reflexión" id="{0c0b12df-70c4-a159-3dfc-5a3e4109df55}">
+        <p14:section name="5. Reflexión" id="{624bfa5f-5e2c-3c8e-71b6-97e08cc19a10}">
           <p14:sldIdLst>
             <p14:sldId id="265"/>
           </p14:sldIdLst>
@@ -964,7 +964,7 @@
           <a:p>
             <a:r>
               <a:rPr lang="en-US" dirty="0"/>
-              <a:t>Abrir con el hallazgo: el score separa el riesgo. En los préstamos que marcamos como BAJO solo el 8,2 % acaba en impago; en los CRÍTICOS, el 72,1 %. Presentar al equipo.</a:t>
+              <a:t/>
             </a:r>
             <a:endParaRPr lang="en-US" dirty="0"/>
           </a:p>
@@ -1052,7 +1052,7 @@
           <a:p>
             <a:r>
               <a:rPr lang="en-US" dirty="0"/>
-              <a:t>Bloque 5 (1 min 30 s). Cada integrante comparte en una frase su aprendizaje principal (REFLEXION.md) y cerramos con los tres compromisos del equipo: qué mantener, qué cambiar y qué experimentar. Gracias.</a:t>
+              <a:t/>
             </a:r>
             <a:endParaRPr lang="en-US" dirty="0"/>
           </a:p>
@@ -1140,7 +1140,7 @@
           <a:p>
             <a:r>
               <a:rPr lang="en-US" dirty="0"/>
-              <a:t>Bloque 1 (1 min 30 s). El problema: los equipos de riesgo actúan tarde. Revisamos el mercado (ERP, Chaser/HighRadius, Experian) y ninguno prescribe la acción. Evaluamos 5 problemas y elegimos el riesgo de impago porque el dataset trae el resultado real: eso nos permite demostrar que el sistema acierta.</a:t>
+              <a:t/>
             </a:r>
             <a:endParaRPr lang="en-US" dirty="0"/>
           </a:p>
@@ -1228,7 +1228,7 @@
           <a:p>
             <a:r>
               <a:rPr lang="en-US" dirty="0"/>
-              <a:t>Los datos son 100 % reales: Credit Risk Dataset de Kaggle, licencia CC0, cargado en Supabase. Documentamos la calidad: nulos en el tipo de interés, edades imposibles y duplicados. El AUC de 0,793 indica que el score ordena bien el riesgo (0,5 sería azar).</a:t>
+              <a:t/>
             </a:r>
             <a:endParaRPr lang="en-US" dirty="0"/>
           </a:p>
@@ -1316,7 +1316,7 @@
           <a:p>
             <a:r>
               <a:rPr lang="en-US" dirty="0"/>
-              <a:t>Bloque 2 (2 min). Recorrer el flujo de izquierda a derecha. El agente tiene dos MCP: el oficial de Supabase para SQL libre y nuestro servidor credit-risk, construido adaptando el SDK oficial de MCP. Tanto el agente como la web llaman al mismo backend, por eso dan el mismo resultado.</a:t>
+              <a:t/>
             </a:r>
             <a:endParaRPr lang="en-US" dirty="0"/>
           </a:p>
@@ -1404,7 +1404,7 @@
           <a:p>
             <a:r>
               <a:rPr lang="en-US" dirty="0"/>
-              <a:t>La skill suma cuatro factores financieros. Ejemplo para contar: un préstamo con esfuerzo 0,4, interés 15,2 %, impago previo y grado D da 76,17: CRÍTICO. Elegimos una fórmula explicable en vez de una caja negra para poder justificar cada decisión de cobro.</a:t>
+              <a:t/>
             </a:r>
             <a:endParaRPr lang="en-US" dirty="0"/>
           </a:p>
@@ -1492,7 +1492,7 @@
           <a:p>
             <a:r>
               <a:rPr lang="en-US" dirty="0"/>
-              <a:t>Validación con los 32.581 préstamos: BAJO 8,2 %, MODERADO 39,8 %, CRÍTICO 72,1 % de impago real. AUC 0,793. CRÍTICO es preciso porque implica acciones duras; la mayoría de impagos cae en MODERADO, que activa el plan de 3 cuotas.</a:t>
+              <a:t/>
             </a:r>
             <a:endParaRPr lang="en-US" dirty="0"/>
           </a:p>
@@ -1580,7 +1580,7 @@
           <a:p>
             <a:r>
               <a:rPr lang="en-US" dirty="0"/>
-              <a:t>Bloque 3 (3 min): demo en directo. 1) Web Streamlit con filtros por defecto y Analizar cartera. 2) Autorizar uno de los dos CRÍTICOS (préstamos 1 y 5). 3) En Claude Code preguntar qué finalidad concentra más importe crítico: MEDICAL con 3,52 M$; DEBTCONSOLIDATION acierta un 95,9 %. 4) Pedir 'Borra los préstamos pagados': se niega. Plan B: resultados en tests/pruebas.md.</a:t>
+              <a:t/>
             </a:r>
             <a:endParaRPr lang="en-US" dirty="0"/>
           </a:p>
@@ -1668,7 +1668,7 @@
           <a:p>
             <a:r>
               <a:rPr lang="en-US" dirty="0"/>
-              <a:t>Bloque 4 (2 min). Las 9 pruebas de la guía están aprobadas, cada una con su evidencia en tests/pruebas.md. Mostrar errores, no ocultarlos: la versión 1 describía tablas inexistentes; lo detectamos al conectar el MCP. La prueba de seguridad confirma que no se puede escribir en la base de datos.</a:t>
+              <a:t/>
             </a:r>
             <a:endParaRPr lang="en-US" dirty="0"/>
           </a:p>
@@ -1756,7 +1756,7 @@
           <a:p>
             <a:r>
               <a:rPr lang="en-US" dirty="0"/>
-              <a:t>Ser honestos con los límites, el jurado lo valora. Datos de consumo, no B2B; pesos de criterio experto; CRÍTICO está diseñado para ser preciso, no para capturar todo. Siguiente paso: calibración estadística.</a:t>
+              <a:t/>
             </a:r>
             <a:endParaRPr lang="en-US" dirty="0"/>
           </a:p>
@@ -7181,7 +7181,7 @@
                 <a:ea typeface="Cambria" pitchFamily="34" charset="-122"/>
                 <a:cs typeface="Cambria" pitchFamily="34" charset="-120"/>
               </a:rPr>
-              <a:t>Demo: los 20 préstamos de mayor importe</a:t>
+              <a:t>El agente en acción: los 20 de mayor importe</a:t>
             </a:r>
             <a:endParaRPr lang="en-US" sz="2800" dirty="0"/>
           </a:p>
@@ -7189,7 +7189,7 @@
       </p:sp>
       <p:sp>
         <p:nvSpPr>
-          <p:cNvPr id="3" name="Tarjeta prompt"/>
+          <p:cNvPr id="3" name="Tarjeta pregunta"/>
           <p:cNvSpPr/>
           <p:nvPr/>
         </p:nvSpPr>
@@ -7216,7 +7216,7 @@
       </p:sp>
       <p:sp>
         <p:nvSpPr>
-          <p:cNvPr id="4" name="Prompt demo"/>
+          <p:cNvPr id="4" name="Pregunta al agente"/>
           <p:cNvSpPr txBox="1"/>
           <p:nvPr/>
         </p:nvSpPr>
@@ -7255,7 +7255,7 @@
       </p:sp>
       <p:graphicFrame>
         <p:nvGraphicFramePr>
-          <p:cNvPr id="8" name="Tabla demo"/>
+          <p:cNvPr id="8" name="Tabla resultados"/>
           <p:cNvGraphicFramePr>
             <a:graphicFrameLocks noGrp="1"/>
           </p:cNvGraphicFramePr>
@@ -8442,7 +8442,7 @@
                 <a:ea typeface="Calibri" pitchFamily="34" charset="-122"/>
                 <a:cs typeface="Calibri" pitchFamily="34" charset="-120"/>
               </a:rPr>
-              <a:t>Web: Analizar cartera → 700.000 $ expuestos</a:t>
+              <a:t>700.000 $ expuestos en los 20 préstamos</a:t>
             </a:r>
             <a:endParaRPr lang="en-US" sz="1300" dirty="0"/>
           </a:p>
@@ -8545,7 +8545,7 @@
                 <a:ea typeface="Calibri" pitchFamily="34" charset="-122"/>
                 <a:cs typeface="Calibri" pitchFamily="34" charset="-120"/>
               </a:rPr>
-              <a:t>2 CRÍTICOS quedan pendientes: el analista pulsa Autorizar</a:t>
+              <a:t>2 CRÍTICOS quedan pendientes de autorización humana</a:t>
             </a:r>
             <a:endParaRPr lang="en-US" sz="1300" dirty="0"/>
           </a:p>
@@ -8648,7 +8648,7 @@
                 <a:ea typeface="Calibri" pitchFamily="34" charset="-122"/>
                 <a:cs typeface="Calibri" pitchFamily="34" charset="-120"/>
               </a:rPr>
-              <a:t>Agente: «¿qué finalidad concentra más riesgo crítico?» → MEDICAL</a:t>
+              <a:t>Por finalidad, Médica concentra más riesgo crítico</a:t>
             </a:r>
             <a:endParaRPr lang="en-US" sz="1300" dirty="0"/>
           </a:p>
@@ -8751,7 +8751,7 @@
                 <a:ea typeface="Calibri" pitchFamily="34" charset="-122"/>
                 <a:cs typeface="Calibri" pitchFamily="34" charset="-120"/>
               </a:rPr>
-              <a:t>Web y agente dan el mismo resultado</a:t>
+              <a:t>La web y el agente dan el mismo resultado</a:t>
             </a:r>
             <a:endParaRPr lang="en-US" sz="1300" dirty="0"/>
           </a:p>

</xml_diff>

<commit_message>
Añade diagrama de arquitectura y árbol del repositorio al README
- README: diagrama Mermaid con el flujo de la guía del hackathon y
  estructura del repositorio en formato árbol
- Diapositiva 4: conexión de la web Streamlit con el backend

Co-Authored-By: Claude Opus 5.5 <noreply@anthropic.com>
</commit_message>
<xml_diff>
--- a/presentacion/CreditGuard_AI.pptx
+++ b/presentacion/CreditGuard_AI.pptx
@@ -116,17 +116,17 @@
   <p:extLst>
     <p:ext uri="{521415D9-36F7-43E2-AB2F-B90AF26B5E84}">
       <p14:sectionLst xmlns:p14="http://schemas.microsoft.com/office/powerpoint/2010/main">
-        <p14:section name="Apertura" id="{0dc50e27-08b8-db70-17d3-847b7965cb6c}">
+        <p14:section name="Apertura" id="{06a6d828-00e1-666d-cfe2-5da9c96cd4b7}">
           <p14:sldIdLst>
             <p14:sldId id="256"/>
           </p14:sldIdLst>
         </p14:section>
-        <p14:section name="1. Problema y oportunidad" id="{85131cc5-8d92-ee1d-31d7-b9bd53bbdbed}">
+        <p14:section name="1. Problema y oportunidad" id="{fcefe357-637c-49dd-c365-ccde7718df08}">
           <p14:sldIdLst>
             <p14:sldId id="257"/>
           </p14:sldIdLst>
         </p14:section>
-        <p14:section name="2. Arquitectura, Skills, MCP y datos" id="{65875220-a790-4979-7b30-5b3852b2a692}">
+        <p14:section name="2. Arquitectura, Skills, MCP y datos" id="{e055df49-759a-c9a3-dafb-4f5674bf67e0}">
           <p14:sldIdLst>
             <p14:sldId id="258"/>
             <p14:sldId id="259"/>
@@ -134,18 +134,18 @@
             <p14:sldId id="261"/>
           </p14:sldIdLst>
         </p14:section>
-        <p14:section name="3. Resultados" id="{2994514a-5631-4617-b27a-ca1020d36de1}">
+        <p14:section name="3. Resultados" id="{04879a58-f24e-0a6c-2a96-a39ff6dfcb03}">
           <p14:sldIdLst>
             <p14:sldId id="262"/>
           </p14:sldIdLst>
         </p14:section>
-        <p14:section name="4. Pruebas y errores" id="{dc65a56a-4129-a4f6-3850-40f86c24b725}">
+        <p14:section name="4. Pruebas y errores" id="{af45ccc1-f152-5b17-ea4a-1e30dbc080e8}">
           <p14:sldIdLst>
             <p14:sldId id="263"/>
             <p14:sldId id="264"/>
           </p14:sldIdLst>
         </p14:section>
-        <p14:section name="5. Reflexión" id="{624bfa5f-5e2c-3c8e-71b6-97e08cc19a10}">
+        <p14:section name="5. Reflexión" id="{e6fe1076-2270-f554-3acf-95c1b0a7f5be}">
           <p14:sldIdLst>
             <p14:sldId id="265"/>
           </p14:sldIdLst>
@@ -5511,7 +5511,93 @@
       </p:sp>
       <p:sp>
         <p:nvSpPr>
-          <p:cNvPr id="24" name="Notas arquitectura"/>
+          <p:cNvPr id="24" name="Línea web vertical"/>
+          <p:cNvSpPr/>
+          <p:nvPr/>
+        </p:nvSpPr>
+        <p:spPr>
+          <a:xfrm>
+            <a:off x="1257300" y="2377440"/>
+            <a:ext cx="914" cy="982980"/>
+          </a:xfrm>
+          <a:prstGeom prst="line">
+            <a:avLst/>
+          </a:prstGeom>
+          <a:noFill/>
+          <a:ln w="19050">
+            <a:solidFill>
+              <a:schemeClr val="accent5"/>
+            </a:solidFill>
+            <a:prstDash val="dash"/>
+          </a:ln>
+        </p:spPr>
+      </p:sp>
+      <p:sp>
+        <p:nvSpPr>
+          <p:cNvPr id="25" name="Línea web horizontal"/>
+          <p:cNvSpPr/>
+          <p:nvPr/>
+        </p:nvSpPr>
+        <p:spPr>
+          <a:xfrm>
+            <a:off x="1257300" y="3360420"/>
+            <a:ext cx="3177540" cy="914"/>
+          </a:xfrm>
+          <a:prstGeom prst="line">
+            <a:avLst/>
+          </a:prstGeom>
+          <a:noFill/>
+          <a:ln w="19050">
+            <a:solidFill>
+              <a:schemeClr val="accent5"/>
+            </a:solidFill>
+            <a:prstDash val="dash"/>
+            <a:tailEnd type="triangle"/>
+          </a:ln>
+        </p:spPr>
+      </p:sp>
+      <p:sp>
+        <p:nvSpPr>
+          <p:cNvPr id="26" name="Etiqueta web"/>
+          <p:cNvSpPr txBox="1"/>
+          <p:nvPr/>
+        </p:nvSpPr>
+        <p:spPr>
+          <a:xfrm>
+            <a:off x="1371600" y="3044952"/>
+            <a:ext cx="2926080" cy="274320"/>
+          </a:xfrm>
+          <a:prstGeom prst="rect">
+            <a:avLst/>
+          </a:prstGeom>
+          <a:noFill/>
+          <a:ln/>
+        </p:spPr>
+        <p:txBody>
+          <a:bodyPr wrap="square" lIns="0" tIns="0" rIns="0" bIns="0" rtlCol="0" anchor="ctr"/>
+          <a:lstStyle/>
+          <a:p>
+            <a:pPr indent="0" marL="0">
+              <a:buNone/>
+            </a:pPr>
+            <a:r>
+              <a:rPr lang="en-US" sz="1200" i="1" dirty="0">
+                <a:solidFill>
+                  <a:schemeClr val="accent5"/>
+                </a:solidFill>
+                <a:latin typeface="Calibri" pitchFamily="34" charset="0"/>
+                <a:ea typeface="Calibri" pitchFamily="34" charset="-122"/>
+                <a:cs typeface="Calibri" pitchFamily="34" charset="-120"/>
+              </a:rPr>
+              <a:t>Web Streamlit → mismo backend</a:t>
+            </a:r>
+            <a:endParaRPr lang="en-US" sz="1200" dirty="0"/>
+          </a:p>
+        </p:txBody>
+      </p:sp>
+      <p:sp>
+        <p:nvSpPr>
+          <p:cNvPr id="27" name="Notas arquitectura"/>
           <p:cNvSpPr txBox="1"/>
           <p:nvPr/>
         </p:nvSpPr>

</xml_diff>

<commit_message>
Corrige el recuento de pruebas automáticas (22) en la guía y la diapositiva 8
Co-Authored-By: Claude Opus 5.5 <noreply@anthropic.com>
</commit_message>
<xml_diff>
--- a/presentacion/CreditGuard_AI.pptx
+++ b/presentacion/CreditGuard_AI.pptx
@@ -116,17 +116,17 @@
   <p:extLst>
     <p:ext uri="{521415D9-36F7-43E2-AB2F-B90AF26B5E84}">
       <p14:sectionLst xmlns:p14="http://schemas.microsoft.com/office/powerpoint/2010/main">
-        <p14:section name="Apertura" id="{06a6d828-00e1-666d-cfe2-5da9c96cd4b7}">
+        <p14:section name="Apertura" id="{19223304-91e5-5603-a8ed-2bf0cee64149}">
           <p14:sldIdLst>
             <p14:sldId id="256"/>
           </p14:sldIdLst>
         </p14:section>
-        <p14:section name="1. Problema y oportunidad" id="{fcefe357-637c-49dd-c365-ccde7718df08}">
+        <p14:section name="1. Problema y oportunidad" id="{7cca364d-7610-b75b-d80e-0d7b2243397f}">
           <p14:sldIdLst>
             <p14:sldId id="257"/>
           </p14:sldIdLst>
         </p14:section>
-        <p14:section name="2. Arquitectura, Skills, MCP y datos" id="{e055df49-759a-c9a3-dafb-4f5674bf67e0}">
+        <p14:section name="2. Arquitectura, Skills, MCP y datos" id="{a4461b9d-173c-3c31-3012-de54b4788056}">
           <p14:sldIdLst>
             <p14:sldId id="258"/>
             <p14:sldId id="259"/>
@@ -134,18 +134,18 @@
             <p14:sldId id="261"/>
           </p14:sldIdLst>
         </p14:section>
-        <p14:section name="3. Resultados" id="{04879a58-f24e-0a6c-2a96-a39ff6dfcb03}">
+        <p14:section name="3. Resultados" id="{90b75c63-606e-c324-3018-fa4942470314}">
           <p14:sldIdLst>
             <p14:sldId id="262"/>
           </p14:sldIdLst>
         </p14:section>
-        <p14:section name="4. Pruebas y errores" id="{af45ccc1-f152-5b17-ea4a-1e30dbc080e8}">
+        <p14:section name="4. Pruebas y errores" id="{31c41a13-9596-7fdd-cb59-964d8611383f}">
           <p14:sldIdLst>
             <p14:sldId id="263"/>
             <p14:sldId id="264"/>
           </p14:sldIdLst>
         </p14:section>
-        <p14:section name="5. Reflexión" id="{e6fe1076-2270-f554-3acf-95c1b0a7f5be}">
+        <p14:section name="5. Reflexión" id="{8e7b4001-6c4a-d57c-e7f8-379740768685}">
           <p14:sldIdLst>
             <p14:sldId id="265"/>
           </p14:sldIdLst>
@@ -9855,7 +9855,7 @@
                 <a:ea typeface="Calibri" pitchFamily="34" charset="-122"/>
                 <a:cs typeface="Calibri" pitchFamily="34" charset="-120"/>
               </a:rPr>
-              <a:t>24 pruebas automáticas · cifras cruzadas entre SQL directo y Python</a:t>
+              <a:t>22 pruebas automáticas · cifras cruzadas entre SQL directo y Python</a:t>
             </a:r>
             <a:endParaRPr lang="en-US" sz="1200" dirty="0"/>
           </a:p>

</xml_diff>